<commit_message>
updated science meeting talk
</commit_message>
<xml_diff>
--- a/2026_lemontree_allocation/src/lt_science_allocation_smith.pptx
+++ b/2026_lemontree_allocation/src/lt_science_allocation_smith.pptx
@@ -12,18 +12,18 @@
     <p:sldId id="260" r:id="rId6"/>
     <p:sldId id="261" r:id="rId7"/>
     <p:sldId id="262" r:id="rId8"/>
-    <p:sldId id="263" r:id="rId9"/>
-    <p:sldId id="264" r:id="rId10"/>
-    <p:sldId id="268" r:id="rId11"/>
-    <p:sldId id="274" r:id="rId12"/>
-    <p:sldId id="275" r:id="rId13"/>
-    <p:sldId id="269" r:id="rId14"/>
-    <p:sldId id="276" r:id="rId15"/>
-    <p:sldId id="277" r:id="rId16"/>
-    <p:sldId id="270" r:id="rId17"/>
-    <p:sldId id="278" r:id="rId18"/>
-    <p:sldId id="279" r:id="rId19"/>
-    <p:sldId id="271" r:id="rId20"/>
+    <p:sldId id="268" r:id="rId9"/>
+    <p:sldId id="274" r:id="rId10"/>
+    <p:sldId id="275" r:id="rId11"/>
+    <p:sldId id="269" r:id="rId12"/>
+    <p:sldId id="276" r:id="rId13"/>
+    <p:sldId id="277" r:id="rId14"/>
+    <p:sldId id="270" r:id="rId15"/>
+    <p:sldId id="278" r:id="rId16"/>
+    <p:sldId id="279" r:id="rId17"/>
+    <p:sldId id="281" r:id="rId18"/>
+    <p:sldId id="271" r:id="rId19"/>
+    <p:sldId id="280" r:id="rId20"/>
     <p:sldId id="272" r:id="rId21"/>
   </p:sldIdLst>
   <p:sldSz cx="12192000" cy="6858000"/>
@@ -123,6 +123,11 @@
       </a:defRPr>
     </a:lvl9pPr>
   </p:defaultTextStyle>
+  <p:extLst>
+    <p:ext uri="{EFAFB233-063F-42B5-8137-9DF3F51BA10A}">
+      <p15:sldGuideLst xmlns:p15="http://schemas.microsoft.com/office/powerpoint/2012/main"/>
+    </p:ext>
+  </p:extLst>
 </p:presentation>
 </file>
 
@@ -273,7 +278,7 @@
           <a:p>
             <a:fld id="{8A914372-A3AC-7946-8026-7C3ECE4DF88D}" type="datetimeFigureOut">
               <a:rPr lang="en-US" smtClean="0"/>
-              <a:t>5/11/26</a:t>
+              <a:t>5/15/26</a:t>
             </a:fld>
             <a:endParaRPr lang="en-US"/>
           </a:p>
@@ -471,7 +476,7 @@
           <a:p>
             <a:fld id="{8A914372-A3AC-7946-8026-7C3ECE4DF88D}" type="datetimeFigureOut">
               <a:rPr lang="en-US" smtClean="0"/>
-              <a:t>5/11/26</a:t>
+              <a:t>5/15/26</a:t>
             </a:fld>
             <a:endParaRPr lang="en-US"/>
           </a:p>
@@ -679,7 +684,7 @@
           <a:p>
             <a:fld id="{8A914372-A3AC-7946-8026-7C3ECE4DF88D}" type="datetimeFigureOut">
               <a:rPr lang="en-US" smtClean="0"/>
-              <a:t>5/11/26</a:t>
+              <a:t>5/15/26</a:t>
             </a:fld>
             <a:endParaRPr lang="en-US"/>
           </a:p>
@@ -877,7 +882,7 @@
           <a:p>
             <a:fld id="{8A914372-A3AC-7946-8026-7C3ECE4DF88D}" type="datetimeFigureOut">
               <a:rPr lang="en-US" smtClean="0"/>
-              <a:t>5/11/26</a:t>
+              <a:t>5/15/26</a:t>
             </a:fld>
             <a:endParaRPr lang="en-US"/>
           </a:p>
@@ -1152,7 +1157,7 @@
           <a:p>
             <a:fld id="{8A914372-A3AC-7946-8026-7C3ECE4DF88D}" type="datetimeFigureOut">
               <a:rPr lang="en-US" smtClean="0"/>
-              <a:t>5/11/26</a:t>
+              <a:t>5/15/26</a:t>
             </a:fld>
             <a:endParaRPr lang="en-US"/>
           </a:p>
@@ -1417,7 +1422,7 @@
           <a:p>
             <a:fld id="{8A914372-A3AC-7946-8026-7C3ECE4DF88D}" type="datetimeFigureOut">
               <a:rPr lang="en-US" smtClean="0"/>
-              <a:t>5/11/26</a:t>
+              <a:t>5/15/26</a:t>
             </a:fld>
             <a:endParaRPr lang="en-US"/>
           </a:p>
@@ -1829,7 +1834,7 @@
           <a:p>
             <a:fld id="{8A914372-A3AC-7946-8026-7C3ECE4DF88D}" type="datetimeFigureOut">
               <a:rPr lang="en-US" smtClean="0"/>
-              <a:t>5/11/26</a:t>
+              <a:t>5/15/26</a:t>
             </a:fld>
             <a:endParaRPr lang="en-US"/>
           </a:p>
@@ -1970,7 +1975,7 @@
           <a:p>
             <a:fld id="{8A914372-A3AC-7946-8026-7C3ECE4DF88D}" type="datetimeFigureOut">
               <a:rPr lang="en-US" smtClean="0"/>
-              <a:t>5/11/26</a:t>
+              <a:t>5/15/26</a:t>
             </a:fld>
             <a:endParaRPr lang="en-US"/>
           </a:p>
@@ -2083,7 +2088,7 @@
           <a:p>
             <a:fld id="{8A914372-A3AC-7946-8026-7C3ECE4DF88D}" type="datetimeFigureOut">
               <a:rPr lang="en-US" smtClean="0"/>
-              <a:t>5/11/26</a:t>
+              <a:t>5/15/26</a:t>
             </a:fld>
             <a:endParaRPr lang="en-US"/>
           </a:p>
@@ -2394,7 +2399,7 @@
           <a:p>
             <a:fld id="{8A914372-A3AC-7946-8026-7C3ECE4DF88D}" type="datetimeFigureOut">
               <a:rPr lang="en-US" smtClean="0"/>
-              <a:t>5/11/26</a:t>
+              <a:t>5/15/26</a:t>
             </a:fld>
             <a:endParaRPr lang="en-US"/>
           </a:p>
@@ -2682,7 +2687,7 @@
           <a:p>
             <a:fld id="{8A914372-A3AC-7946-8026-7C3ECE4DF88D}" type="datetimeFigureOut">
               <a:rPr lang="en-US" smtClean="0"/>
-              <a:t>5/11/26</a:t>
+              <a:t>5/15/26</a:t>
             </a:fld>
             <a:endParaRPr lang="en-US"/>
           </a:p>
@@ -2923,7 +2928,7 @@
           <a:p>
             <a:fld id="{8A914372-A3AC-7946-8026-7C3ECE4DF88D}" type="datetimeFigureOut">
               <a:rPr lang="en-US" smtClean="0"/>
-              <a:t>5/11/26</a:t>
+              <a:t>5/15/26</a:t>
             </a:fld>
             <a:endParaRPr lang="en-US"/>
           </a:p>
@@ -3397,7 +3402,13 @@
           <a:p>
             <a:r>
               <a:rPr lang="en-US" dirty="0"/>
-              <a:t>LEMONTREE Science meeting May 21, 2026</a:t>
+              <a:t>LEMONTREE Science meeting</a:t>
+            </a:r>
+          </a:p>
+          <a:p>
+            <a:r>
+              <a:rPr lang="en-US" dirty="0"/>
+              <a:t>May 21, 2026</a:t>
             </a:r>
           </a:p>
         </p:txBody>
@@ -3416,404 +3427,6 @@
 </file>
 
 <file path=ppt/slides/slide10.xml><?xml version="1.0" encoding="utf-8"?>
-<p:sld xmlns:a="http://schemas.openxmlformats.org/drawingml/2006/main" xmlns:r="http://schemas.openxmlformats.org/officeDocument/2006/relationships" xmlns:p="http://schemas.openxmlformats.org/presentationml/2006/main">
-  <p:cSld>
-    <p:spTree>
-      <p:nvGrpSpPr>
-        <p:cNvPr id="1" name="">
-          <a:extLst>
-            <a:ext uri="{FF2B5EF4-FFF2-40B4-BE49-F238E27FC236}">
-              <a16:creationId xmlns:a16="http://schemas.microsoft.com/office/drawing/2014/main" id="{081F4B8E-FFCB-C7E4-912F-E1E7B83742CF}"/>
-            </a:ext>
-          </a:extLst>
-        </p:cNvPr>
-        <p:cNvGrpSpPr/>
-        <p:nvPr/>
-      </p:nvGrpSpPr>
-      <p:grpSpPr>
-        <a:xfrm>
-          <a:off x="0" y="0"/>
-          <a:ext cx="0" cy="0"/>
-          <a:chOff x="0" y="0"/>
-          <a:chExt cx="0" cy="0"/>
-        </a:xfrm>
-      </p:grpSpPr>
-      <p:sp>
-        <p:nvSpPr>
-          <p:cNvPr id="2" name="Title 1">
-            <a:extLst>
-              <a:ext uri="{FF2B5EF4-FFF2-40B4-BE49-F238E27FC236}">
-                <a16:creationId xmlns:a16="http://schemas.microsoft.com/office/drawing/2014/main" id="{C4E0AF7A-3584-14C5-8D91-8E04A4C1F06C}"/>
-              </a:ext>
-            </a:extLst>
-          </p:cNvPr>
-          <p:cNvSpPr>
-            <a:spLocks noGrp="1"/>
-          </p:cNvSpPr>
-          <p:nvPr>
-            <p:ph type="title"/>
-          </p:nvPr>
-        </p:nvSpPr>
-        <p:spPr/>
-        <p:txBody>
-          <a:bodyPr/>
-          <a:lstStyle/>
-          <a:p>
-            <a:r>
-              <a:rPr lang="en-US" dirty="0"/>
-              <a:t>Experiment 1: Light x Soil Nitrogen x N-fixation</a:t>
-            </a:r>
-          </a:p>
-        </p:txBody>
-      </p:sp>
-      <p:sp>
-        <p:nvSpPr>
-          <p:cNvPr id="3" name="Content Placeholder 2">
-            <a:extLst>
-              <a:ext uri="{FF2B5EF4-FFF2-40B4-BE49-F238E27FC236}">
-                <a16:creationId xmlns:a16="http://schemas.microsoft.com/office/drawing/2014/main" id="{F41BEB87-60E9-D1AD-502B-EBF94F330296}"/>
-              </a:ext>
-            </a:extLst>
-          </p:cNvPr>
-          <p:cNvSpPr>
-            <a:spLocks noGrp="1"/>
-          </p:cNvSpPr>
-          <p:nvPr>
-            <p:ph idx="1"/>
-          </p:nvPr>
-        </p:nvSpPr>
-        <p:spPr/>
-        <p:txBody>
-          <a:bodyPr>
-            <a:normAutofit/>
-          </a:bodyPr>
-          <a:lstStyle/>
-          <a:p>
-            <a:r>
-              <a:rPr lang="en-US" dirty="0"/>
-              <a:t>Within leaves</a:t>
-            </a:r>
-          </a:p>
-          <a:p>
-            <a:pPr lvl="1"/>
-            <a:r>
-              <a:rPr lang="en-US" dirty="0">
-                <a:solidFill>
-                  <a:srgbClr val="002060"/>
-                </a:solidFill>
-              </a:rPr>
-              <a:t>Nitrogen allocation</a:t>
-            </a:r>
-          </a:p>
-          <a:p>
-            <a:pPr lvl="1"/>
-            <a:r>
-              <a:rPr lang="en-US" dirty="0">
-                <a:solidFill>
-                  <a:schemeClr val="bg1">
-                    <a:lumMod val="85000"/>
-                  </a:schemeClr>
-                </a:solidFill>
-              </a:rPr>
-              <a:t>Phosphorus allocation</a:t>
-            </a:r>
-          </a:p>
-          <a:p>
-            <a:r>
-              <a:rPr lang="en-US" dirty="0"/>
-              <a:t>Whole plant</a:t>
-            </a:r>
-          </a:p>
-          <a:p>
-            <a:pPr lvl="1"/>
-            <a:r>
-              <a:rPr lang="en-US" dirty="0" err="1">
-                <a:solidFill>
-                  <a:srgbClr val="002060"/>
-                </a:solidFill>
-              </a:rPr>
-              <a:t>Root:Shoot</a:t>
-            </a:r>
-            <a:r>
-              <a:rPr lang="en-US" dirty="0">
-                <a:solidFill>
-                  <a:srgbClr val="002060"/>
-                </a:solidFill>
-              </a:rPr>
-              <a:t> ratio</a:t>
-            </a:r>
-          </a:p>
-          <a:p>
-            <a:pPr lvl="1"/>
-            <a:r>
-              <a:rPr lang="en-US" dirty="0">
-                <a:solidFill>
-                  <a:srgbClr val="002060"/>
-                </a:solidFill>
-              </a:rPr>
-              <a:t>Total leaf area</a:t>
-            </a:r>
-          </a:p>
-        </p:txBody>
-      </p:sp>
-    </p:spTree>
-    <p:extLst>
-      <p:ext uri="{BB962C8B-B14F-4D97-AF65-F5344CB8AC3E}">
-        <p14:creationId xmlns:p14="http://schemas.microsoft.com/office/powerpoint/2010/main" val="2180978967"/>
-      </p:ext>
-    </p:extLst>
-  </p:cSld>
-  <p:clrMapOvr>
-    <a:masterClrMapping/>
-  </p:clrMapOvr>
-</p:sld>
-</file>
-
-<file path=ppt/slides/slide11.xml><?xml version="1.0" encoding="utf-8"?>
-<p:sld xmlns:a="http://schemas.openxmlformats.org/drawingml/2006/main" xmlns:r="http://schemas.openxmlformats.org/officeDocument/2006/relationships" xmlns:p="http://schemas.openxmlformats.org/presentationml/2006/main">
-  <p:cSld>
-    <p:spTree>
-      <p:nvGrpSpPr>
-        <p:cNvPr id="1" name="">
-          <a:extLst>
-            <a:ext uri="{FF2B5EF4-FFF2-40B4-BE49-F238E27FC236}">
-              <a16:creationId xmlns:a16="http://schemas.microsoft.com/office/drawing/2014/main" id="{2B3C35B5-F04B-6C9F-52D1-F3C6AD3D6B98}"/>
-            </a:ext>
-          </a:extLst>
-        </p:cNvPr>
-        <p:cNvGrpSpPr/>
-        <p:nvPr/>
-      </p:nvGrpSpPr>
-      <p:grpSpPr>
-        <a:xfrm>
-          <a:off x="0" y="0"/>
-          <a:ext cx="0" cy="0"/>
-          <a:chOff x="0" y="0"/>
-          <a:chExt cx="0" cy="0"/>
-        </a:xfrm>
-      </p:grpSpPr>
-      <p:sp>
-        <p:nvSpPr>
-          <p:cNvPr id="2" name="Title 1">
-            <a:extLst>
-              <a:ext uri="{FF2B5EF4-FFF2-40B4-BE49-F238E27FC236}">
-                <a16:creationId xmlns:a16="http://schemas.microsoft.com/office/drawing/2014/main" id="{49A87D41-9FE2-9D5A-203F-D1213E8F606C}"/>
-              </a:ext>
-            </a:extLst>
-          </p:cNvPr>
-          <p:cNvSpPr>
-            <a:spLocks noGrp="1"/>
-          </p:cNvSpPr>
-          <p:nvPr>
-            <p:ph type="title"/>
-          </p:nvPr>
-        </p:nvSpPr>
-        <p:spPr/>
-        <p:txBody>
-          <a:bodyPr/>
-          <a:lstStyle/>
-          <a:p>
-            <a:r>
-              <a:rPr lang="en-US" dirty="0"/>
-              <a:t>Experiment 1: Light x Soil Nitrogen x N-fixation</a:t>
-            </a:r>
-          </a:p>
-        </p:txBody>
-      </p:sp>
-      <p:sp>
-        <p:nvSpPr>
-          <p:cNvPr id="3" name="Content Placeholder 2">
-            <a:extLst>
-              <a:ext uri="{FF2B5EF4-FFF2-40B4-BE49-F238E27FC236}">
-                <a16:creationId xmlns:a16="http://schemas.microsoft.com/office/drawing/2014/main" id="{27F9FF13-E5CF-A6B8-A870-69D4C81F1D71}"/>
-              </a:ext>
-            </a:extLst>
-          </p:cNvPr>
-          <p:cNvSpPr>
-            <a:spLocks noGrp="1"/>
-          </p:cNvSpPr>
-          <p:nvPr>
-            <p:ph idx="1"/>
-          </p:nvPr>
-        </p:nvSpPr>
-        <p:spPr>
-          <a:xfrm>
-            <a:off x="838200" y="1825625"/>
-            <a:ext cx="5257800" cy="4351338"/>
-          </a:xfrm>
-        </p:spPr>
-        <p:txBody>
-          <a:bodyPr>
-            <a:normAutofit/>
-          </a:bodyPr>
-          <a:lstStyle/>
-          <a:p>
-            <a:r>
-              <a:rPr lang="en-US" dirty="0">
-                <a:solidFill>
-                  <a:schemeClr val="bg1">
-                    <a:lumMod val="85000"/>
-                  </a:schemeClr>
-                </a:solidFill>
-              </a:rPr>
-              <a:t>Within leaves</a:t>
-            </a:r>
-          </a:p>
-          <a:p>
-            <a:pPr lvl="1"/>
-            <a:r>
-              <a:rPr lang="en-US" dirty="0">
-                <a:solidFill>
-                  <a:srgbClr val="002060"/>
-                </a:solidFill>
-              </a:rPr>
-              <a:t>Nitrogen allocation</a:t>
-            </a:r>
-          </a:p>
-          <a:p>
-            <a:pPr lvl="1"/>
-            <a:r>
-              <a:rPr lang="en-US" dirty="0">
-                <a:solidFill>
-                  <a:schemeClr val="bg1">
-                    <a:lumMod val="85000"/>
-                  </a:schemeClr>
-                </a:solidFill>
-              </a:rPr>
-              <a:t>Phosphorus allocation</a:t>
-            </a:r>
-          </a:p>
-          <a:p>
-            <a:r>
-              <a:rPr lang="en-US" dirty="0">
-                <a:solidFill>
-                  <a:schemeClr val="bg1">
-                    <a:lumMod val="85000"/>
-                  </a:schemeClr>
-                </a:solidFill>
-              </a:rPr>
-              <a:t>Whole plant</a:t>
-            </a:r>
-          </a:p>
-          <a:p>
-            <a:pPr lvl="1"/>
-            <a:r>
-              <a:rPr lang="en-US" dirty="0" err="1">
-                <a:solidFill>
-                  <a:schemeClr val="bg1">
-                    <a:lumMod val="85000"/>
-                  </a:schemeClr>
-                </a:solidFill>
-              </a:rPr>
-              <a:t>Root:Shoot</a:t>
-            </a:r>
-            <a:r>
-              <a:rPr lang="en-US" dirty="0">
-                <a:solidFill>
-                  <a:schemeClr val="bg1">
-                    <a:lumMod val="85000"/>
-                  </a:schemeClr>
-                </a:solidFill>
-              </a:rPr>
-              <a:t> ratio</a:t>
-            </a:r>
-          </a:p>
-          <a:p>
-            <a:pPr lvl="1"/>
-            <a:r>
-              <a:rPr lang="en-US" dirty="0">
-                <a:solidFill>
-                  <a:schemeClr val="bg1">
-                    <a:lumMod val="85000"/>
-                  </a:schemeClr>
-                </a:solidFill>
-              </a:rPr>
-              <a:t>Total leaf area</a:t>
-            </a:r>
-          </a:p>
-        </p:txBody>
-      </p:sp>
-      <p:sp>
-        <p:nvSpPr>
-          <p:cNvPr id="4" name="TextBox 3">
-            <a:extLst>
-              <a:ext uri="{FF2B5EF4-FFF2-40B4-BE49-F238E27FC236}">
-                <a16:creationId xmlns:a16="http://schemas.microsoft.com/office/drawing/2014/main" id="{AD4CE84B-4FC8-1B3D-7DAB-153060C0C815}"/>
-              </a:ext>
-            </a:extLst>
-          </p:cNvPr>
-          <p:cNvSpPr txBox="1"/>
-          <p:nvPr/>
-        </p:nvSpPr>
-        <p:spPr>
-          <a:xfrm>
-            <a:off x="838199" y="4731488"/>
-            <a:ext cx="5257801" cy="1569660"/>
-          </a:xfrm>
-          <a:prstGeom prst="rect">
-            <a:avLst/>
-          </a:prstGeom>
-          <a:noFill/>
-        </p:spPr>
-        <p:txBody>
-          <a:bodyPr wrap="square" rtlCol="0">
-            <a:spAutoFit/>
-          </a:bodyPr>
-          <a:lstStyle/>
-          <a:p>
-            <a:r>
-              <a:rPr lang="en-US" sz="2400" dirty="0">
-                <a:solidFill>
-                  <a:srgbClr val="FF0000"/>
-                </a:solidFill>
-              </a:rPr>
-              <a:t>Light increases and soil N decreases leaf N allocation to photosynthesis in N-fixing and non-N-fixing species (Waring et al., 2023).</a:t>
-            </a:r>
-          </a:p>
-        </p:txBody>
-      </p:sp>
-      <p:pic>
-        <p:nvPicPr>
-          <p:cNvPr id="5" name="New picture">
-            <a:extLst>
-              <a:ext uri="{FF2B5EF4-FFF2-40B4-BE49-F238E27FC236}">
-                <a16:creationId xmlns:a16="http://schemas.microsoft.com/office/drawing/2014/main" id="{C62D95DF-4132-D77A-BA20-1897BD10C544}"/>
-              </a:ext>
-            </a:extLst>
-          </p:cNvPr>
-          <p:cNvPicPr/>
-          <p:nvPr/>
-        </p:nvPicPr>
-        <p:blipFill>
-          <a:blip r:embed="rId2"/>
-          <a:stretch>
-            <a:fillRect/>
-          </a:stretch>
-        </p:blipFill>
-        <p:spPr>
-          <a:xfrm>
-            <a:off x="6934201" y="1473108"/>
-            <a:ext cx="5257799" cy="5279821"/>
-          </a:xfrm>
-          <a:prstGeom prst="rect">
-            <a:avLst/>
-          </a:prstGeom>
-        </p:spPr>
-      </p:pic>
-    </p:spTree>
-    <p:extLst>
-      <p:ext uri="{BB962C8B-B14F-4D97-AF65-F5344CB8AC3E}">
-        <p14:creationId xmlns:p14="http://schemas.microsoft.com/office/powerpoint/2010/main" val="2639993323"/>
-      </p:ext>
-    </p:extLst>
-  </p:cSld>
-  <p:clrMapOvr>
-    <a:masterClrMapping/>
-  </p:clrMapOvr>
-</p:sld>
-</file>
-
-<file path=ppt/slides/slide12.xml><?xml version="1.0" encoding="utf-8"?>
 <p:sld xmlns:a="http://schemas.openxmlformats.org/drawingml/2006/main" xmlns:r="http://schemas.openxmlformats.org/officeDocument/2006/relationships" xmlns:p="http://schemas.openxmlformats.org/presentationml/2006/main">
   <p:cSld>
     <p:spTree>
@@ -4024,6 +3637,41 @@
           </a:p>
         </p:txBody>
       </p:sp>
+      <p:sp>
+        <p:nvSpPr>
+          <p:cNvPr id="5" name="TextBox 4">
+            <a:extLst>
+              <a:ext uri="{FF2B5EF4-FFF2-40B4-BE49-F238E27FC236}">
+                <a16:creationId xmlns:a16="http://schemas.microsoft.com/office/drawing/2014/main" id="{128A52E5-9E79-E8D8-FA49-50B60469483D}"/>
+              </a:ext>
+            </a:extLst>
+          </p:cNvPr>
+          <p:cNvSpPr txBox="1"/>
+          <p:nvPr/>
+        </p:nvSpPr>
+        <p:spPr>
+          <a:xfrm>
+            <a:off x="9189383" y="6492875"/>
+            <a:ext cx="3002617" cy="369332"/>
+          </a:xfrm>
+          <a:prstGeom prst="rect">
+            <a:avLst/>
+          </a:prstGeom>
+          <a:noFill/>
+        </p:spPr>
+        <p:txBody>
+          <a:bodyPr wrap="none" rtlCol="0">
+            <a:spAutoFit/>
+          </a:bodyPr>
+          <a:lstStyle/>
+          <a:p>
+            <a:r>
+              <a:rPr lang="en-US" dirty="0"/>
+              <a:t>Perkowski et al. (2021, 2024)</a:t>
+            </a:r>
+          </a:p>
+        </p:txBody>
+      </p:sp>
     </p:spTree>
     <p:extLst>
       <p:ext uri="{BB962C8B-B14F-4D97-AF65-F5344CB8AC3E}">
@@ -4037,7 +3685,7 @@
 </p:sld>
 </file>
 
-<file path=ppt/slides/slide13.xml><?xml version="1.0" encoding="utf-8"?>
+<file path=ppt/slides/slide11.xml><?xml version="1.0" encoding="utf-8"?>
 <p:sld xmlns:a="http://schemas.openxmlformats.org/drawingml/2006/main" xmlns:r="http://schemas.openxmlformats.org/officeDocument/2006/relationships" xmlns:p="http://schemas.openxmlformats.org/presentationml/2006/main">
   <p:cSld>
     <p:spTree>
@@ -4186,6 +3834,75 @@
           </a:p>
         </p:txBody>
       </p:sp>
+      <p:pic>
+        <p:nvPicPr>
+          <p:cNvPr id="5" name="Picture 4">
+            <a:extLst>
+              <a:ext uri="{FF2B5EF4-FFF2-40B4-BE49-F238E27FC236}">
+                <a16:creationId xmlns:a16="http://schemas.microsoft.com/office/drawing/2014/main" id="{0CCA4C37-C166-CA73-3CBD-E601D5824419}"/>
+              </a:ext>
+            </a:extLst>
+          </p:cNvPr>
+          <p:cNvPicPr>
+            <a:picLocks noChangeAspect="1"/>
+          </p:cNvPicPr>
+          <p:nvPr/>
+        </p:nvPicPr>
+        <p:blipFill>
+          <a:blip r:embed="rId2"/>
+          <a:stretch>
+            <a:fillRect/>
+          </a:stretch>
+        </p:blipFill>
+        <p:spPr>
+          <a:xfrm>
+            <a:off x="7387919" y="2466038"/>
+            <a:ext cx="3146486" cy="3146486"/>
+          </a:xfrm>
+          <a:prstGeom prst="rect">
+            <a:avLst/>
+          </a:prstGeom>
+        </p:spPr>
+      </p:pic>
+      <p:sp>
+        <p:nvSpPr>
+          <p:cNvPr id="6" name="TextBox 5">
+            <a:extLst>
+              <a:ext uri="{FF2B5EF4-FFF2-40B4-BE49-F238E27FC236}">
+                <a16:creationId xmlns:a16="http://schemas.microsoft.com/office/drawing/2014/main" id="{2F0A4738-D2BD-EEB3-16BB-32FF7AF6D2DB}"/>
+              </a:ext>
+            </a:extLst>
+          </p:cNvPr>
+          <p:cNvSpPr txBox="1"/>
+          <p:nvPr/>
+        </p:nvSpPr>
+        <p:spPr>
+          <a:xfrm>
+            <a:off x="9569359" y="6492875"/>
+            <a:ext cx="2622641" cy="369332"/>
+          </a:xfrm>
+          <a:prstGeom prst="rect">
+            <a:avLst/>
+          </a:prstGeom>
+          <a:noFill/>
+        </p:spPr>
+        <p:txBody>
+          <a:bodyPr wrap="none" rtlCol="0">
+            <a:spAutoFit/>
+          </a:bodyPr>
+          <a:lstStyle/>
+          <a:p>
+            <a:r>
+              <a:rPr lang="en-US" dirty="0" err="1"/>
+              <a:t>Cheaib</a:t>
+            </a:r>
+            <a:r>
+              <a:rPr lang="en-US" dirty="0"/>
+              <a:t> et al. (in revision)</a:t>
+            </a:r>
+          </a:p>
+        </p:txBody>
+      </p:sp>
     </p:spTree>
     <p:extLst>
       <p:ext uri="{BB962C8B-B14F-4D97-AF65-F5344CB8AC3E}">
@@ -4199,7 +3916,7 @@
 </p:sld>
 </file>
 
-<file path=ppt/slides/slide14.xml><?xml version="1.0" encoding="utf-8"?>
+<file path=ppt/slides/slide12.xml><?xml version="1.0" encoding="utf-8"?>
 <p:sld xmlns:a="http://schemas.openxmlformats.org/drawingml/2006/main" xmlns:r="http://schemas.openxmlformats.org/officeDocument/2006/relationships" xmlns:p="http://schemas.openxmlformats.org/presentationml/2006/main">
   <p:cSld>
     <p:spTree>
@@ -4350,6 +4067,84 @@
           </a:p>
         </p:txBody>
       </p:sp>
+      <p:sp>
+        <p:nvSpPr>
+          <p:cNvPr id="4" name="TextBox 3">
+            <a:extLst>
+              <a:ext uri="{FF2B5EF4-FFF2-40B4-BE49-F238E27FC236}">
+                <a16:creationId xmlns:a16="http://schemas.microsoft.com/office/drawing/2014/main" id="{60593747-FA8E-1BC2-12CC-70159DD03CF4}"/>
+              </a:ext>
+            </a:extLst>
+          </p:cNvPr>
+          <p:cNvSpPr txBox="1"/>
+          <p:nvPr/>
+        </p:nvSpPr>
+        <p:spPr>
+          <a:xfrm>
+            <a:off x="5980386" y="3631962"/>
+            <a:ext cx="4090415" cy="769441"/>
+          </a:xfrm>
+          <a:prstGeom prst="rect">
+            <a:avLst/>
+          </a:prstGeom>
+          <a:noFill/>
+        </p:spPr>
+        <p:txBody>
+          <a:bodyPr wrap="none" rtlCol="0">
+            <a:spAutoFit/>
+          </a:bodyPr>
+          <a:lstStyle/>
+          <a:p>
+            <a:r>
+              <a:rPr lang="en-US" sz="4400" dirty="0">
+                <a:solidFill>
+                  <a:srgbClr val="FF0000"/>
+                </a:solidFill>
+              </a:rPr>
+              <a:t>No effect on R:S</a:t>
+            </a:r>
+          </a:p>
+        </p:txBody>
+      </p:sp>
+      <p:sp>
+        <p:nvSpPr>
+          <p:cNvPr id="5" name="TextBox 4">
+            <a:extLst>
+              <a:ext uri="{FF2B5EF4-FFF2-40B4-BE49-F238E27FC236}">
+                <a16:creationId xmlns:a16="http://schemas.microsoft.com/office/drawing/2014/main" id="{AAF39E17-E94B-0DBB-1D49-59F01EE58D8D}"/>
+              </a:ext>
+            </a:extLst>
+          </p:cNvPr>
+          <p:cNvSpPr txBox="1"/>
+          <p:nvPr/>
+        </p:nvSpPr>
+        <p:spPr>
+          <a:xfrm>
+            <a:off x="9569359" y="6492875"/>
+            <a:ext cx="2622641" cy="369332"/>
+          </a:xfrm>
+          <a:prstGeom prst="rect">
+            <a:avLst/>
+          </a:prstGeom>
+          <a:noFill/>
+        </p:spPr>
+        <p:txBody>
+          <a:bodyPr wrap="none" rtlCol="0">
+            <a:spAutoFit/>
+          </a:bodyPr>
+          <a:lstStyle/>
+          <a:p>
+            <a:r>
+              <a:rPr lang="en-US" dirty="0" err="1"/>
+              <a:t>Cheaib</a:t>
+            </a:r>
+            <a:r>
+              <a:rPr lang="en-US" dirty="0"/>
+              <a:t> et al. (in revision)</a:t>
+            </a:r>
+          </a:p>
+        </p:txBody>
+      </p:sp>
     </p:spTree>
     <p:extLst>
       <p:ext uri="{BB962C8B-B14F-4D97-AF65-F5344CB8AC3E}">
@@ -4363,7 +4158,7 @@
 </p:sld>
 </file>
 
-<file path=ppt/slides/slide15.xml><?xml version="1.0" encoding="utf-8"?>
+<file path=ppt/slides/slide13.xml><?xml version="1.0" encoding="utf-8"?>
 <p:sld xmlns:a="http://schemas.openxmlformats.org/drawingml/2006/main" xmlns:r="http://schemas.openxmlformats.org/officeDocument/2006/relationships" xmlns:p="http://schemas.openxmlformats.org/presentationml/2006/main">
   <p:cSld>
     <p:spTree>
@@ -4516,6 +4311,124 @@
           </a:p>
         </p:txBody>
       </p:sp>
+      <p:pic>
+        <p:nvPicPr>
+          <p:cNvPr id="4" name="Picture 3">
+            <a:extLst>
+              <a:ext uri="{FF2B5EF4-FFF2-40B4-BE49-F238E27FC236}">
+                <a16:creationId xmlns:a16="http://schemas.microsoft.com/office/drawing/2014/main" id="{83C79256-89F3-CC03-4AC6-1D837932DE23}"/>
+              </a:ext>
+            </a:extLst>
+          </p:cNvPr>
+          <p:cNvPicPr>
+            <a:picLocks noChangeAspect="1"/>
+          </p:cNvPicPr>
+          <p:nvPr/>
+        </p:nvPicPr>
+        <p:blipFill>
+          <a:blip r:embed="rId2"/>
+          <a:stretch>
+            <a:fillRect/>
+          </a:stretch>
+        </p:blipFill>
+        <p:spPr>
+          <a:xfrm>
+            <a:off x="6096000" y="1825625"/>
+            <a:ext cx="4793072" cy="4206165"/>
+          </a:xfrm>
+          <a:prstGeom prst="rect">
+            <a:avLst/>
+          </a:prstGeom>
+        </p:spPr>
+      </p:pic>
+      <p:sp>
+        <p:nvSpPr>
+          <p:cNvPr id="5" name="TextBox 4">
+            <a:extLst>
+              <a:ext uri="{FF2B5EF4-FFF2-40B4-BE49-F238E27FC236}">
+                <a16:creationId xmlns:a16="http://schemas.microsoft.com/office/drawing/2014/main" id="{FD445FC4-8254-DC5A-83C2-EFFD5E11D926}"/>
+              </a:ext>
+            </a:extLst>
+          </p:cNvPr>
+          <p:cNvSpPr txBox="1"/>
+          <p:nvPr/>
+        </p:nvSpPr>
+        <p:spPr>
+          <a:xfrm>
+            <a:off x="458766" y="4935245"/>
+            <a:ext cx="5172506" cy="954107"/>
+          </a:xfrm>
+          <a:prstGeom prst="rect">
+            <a:avLst/>
+          </a:prstGeom>
+          <a:noFill/>
+        </p:spPr>
+        <p:txBody>
+          <a:bodyPr wrap="none" rtlCol="0">
+            <a:spAutoFit/>
+          </a:bodyPr>
+          <a:lstStyle/>
+          <a:p>
+            <a:r>
+              <a:rPr lang="en-US" sz="2800" dirty="0">
+                <a:solidFill>
+                  <a:srgbClr val="FF0000"/>
+                </a:solidFill>
+              </a:rPr>
+              <a:t>Soil N increases TLA</a:t>
+            </a:r>
+          </a:p>
+          <a:p>
+            <a:r>
+              <a:rPr lang="en-US" sz="2800" dirty="0">
+                <a:solidFill>
+                  <a:srgbClr val="FF0000"/>
+                </a:solidFill>
+              </a:rPr>
+              <a:t>Drought decreases TLA in high N</a:t>
+            </a:r>
+          </a:p>
+        </p:txBody>
+      </p:sp>
+      <p:sp>
+        <p:nvSpPr>
+          <p:cNvPr id="6" name="TextBox 5">
+            <a:extLst>
+              <a:ext uri="{FF2B5EF4-FFF2-40B4-BE49-F238E27FC236}">
+                <a16:creationId xmlns:a16="http://schemas.microsoft.com/office/drawing/2014/main" id="{48B9C591-7A1E-59B7-53BB-79DE8C491988}"/>
+              </a:ext>
+            </a:extLst>
+          </p:cNvPr>
+          <p:cNvSpPr txBox="1"/>
+          <p:nvPr/>
+        </p:nvSpPr>
+        <p:spPr>
+          <a:xfrm>
+            <a:off x="9569359" y="6492875"/>
+            <a:ext cx="2622641" cy="369332"/>
+          </a:xfrm>
+          <a:prstGeom prst="rect">
+            <a:avLst/>
+          </a:prstGeom>
+          <a:noFill/>
+        </p:spPr>
+        <p:txBody>
+          <a:bodyPr wrap="none" rtlCol="0">
+            <a:spAutoFit/>
+          </a:bodyPr>
+          <a:lstStyle/>
+          <a:p>
+            <a:r>
+              <a:rPr lang="en-US" dirty="0" err="1"/>
+              <a:t>Cheaib</a:t>
+            </a:r>
+            <a:r>
+              <a:rPr lang="en-US" dirty="0"/>
+              <a:t> et al. (in revision)</a:t>
+            </a:r>
+          </a:p>
+        </p:txBody>
+      </p:sp>
     </p:spTree>
     <p:extLst>
       <p:ext uri="{BB962C8B-B14F-4D97-AF65-F5344CB8AC3E}">
@@ -4529,7 +4442,7 @@
 </p:sld>
 </file>
 
-<file path=ppt/slides/slide16.xml><?xml version="1.0" encoding="utf-8"?>
+<file path=ppt/slides/slide14.xml><?xml version="1.0" encoding="utf-8"?>
 <p:sld xmlns:a="http://schemas.openxmlformats.org/drawingml/2006/main" xmlns:r="http://schemas.openxmlformats.org/officeDocument/2006/relationships" xmlns:p="http://schemas.openxmlformats.org/presentationml/2006/main">
   <p:cSld>
     <p:spTree>
@@ -4686,6 +4599,77 @@
           </a:p>
         </p:txBody>
       </p:sp>
+      <p:pic>
+        <p:nvPicPr>
+          <p:cNvPr id="4" name="Picture 3">
+            <a:extLst>
+              <a:ext uri="{FF2B5EF4-FFF2-40B4-BE49-F238E27FC236}">
+                <a16:creationId xmlns:a16="http://schemas.microsoft.com/office/drawing/2014/main" id="{B00C5D18-B834-805C-B1AF-3D8E2D6E2D90}"/>
+              </a:ext>
+            </a:extLst>
+          </p:cNvPr>
+          <p:cNvPicPr>
+            <a:picLocks noChangeAspect="1"/>
+          </p:cNvPicPr>
+          <p:nvPr/>
+        </p:nvPicPr>
+        <p:blipFill>
+          <a:blip r:embed="rId2" cstate="print">
+            <a:extLst>
+              <a:ext uri="{28A0092B-C50C-407E-A947-70E740481C1C}">
+                <a14:useLocalDpi xmlns:a14="http://schemas.microsoft.com/office/drawing/2010/main"/>
+              </a:ext>
+            </a:extLst>
+          </a:blip>
+          <a:stretch>
+            <a:fillRect/>
+          </a:stretch>
+        </p:blipFill>
+        <p:spPr>
+          <a:xfrm>
+            <a:off x="7152994" y="2122050"/>
+            <a:ext cx="3483265" cy="3479964"/>
+          </a:xfrm>
+          <a:prstGeom prst="rect">
+            <a:avLst/>
+          </a:prstGeom>
+        </p:spPr>
+      </p:pic>
+      <p:sp>
+        <p:nvSpPr>
+          <p:cNvPr id="5" name="TextBox 4">
+            <a:extLst>
+              <a:ext uri="{FF2B5EF4-FFF2-40B4-BE49-F238E27FC236}">
+                <a16:creationId xmlns:a16="http://schemas.microsoft.com/office/drawing/2014/main" id="{3E1295FB-8B32-77D3-0098-B7BFC0626408}"/>
+              </a:ext>
+            </a:extLst>
+          </p:cNvPr>
+          <p:cNvSpPr txBox="1"/>
+          <p:nvPr/>
+        </p:nvSpPr>
+        <p:spPr>
+          <a:xfrm>
+            <a:off x="9795318" y="6473388"/>
+            <a:ext cx="2396682" cy="369332"/>
+          </a:xfrm>
+          <a:prstGeom prst="rect">
+            <a:avLst/>
+          </a:prstGeom>
+          <a:noFill/>
+        </p:spPr>
+        <p:txBody>
+          <a:bodyPr wrap="none" rtlCol="0">
+            <a:spAutoFit/>
+          </a:bodyPr>
+          <a:lstStyle/>
+          <a:p>
+            <a:r>
+              <a:rPr lang="en-US" dirty="0"/>
+              <a:t>Perkowski et al. (2025)</a:t>
+            </a:r>
+          </a:p>
+        </p:txBody>
+      </p:sp>
     </p:spTree>
     <p:extLst>
       <p:ext uri="{BB962C8B-B14F-4D97-AF65-F5344CB8AC3E}">
@@ -4699,7 +4683,7 @@
 </p:sld>
 </file>
 
-<file path=ppt/slides/slide17.xml><?xml version="1.0" encoding="utf-8"?>
+<file path=ppt/slides/slide15.xml><?xml version="1.0" encoding="utf-8"?>
 <p:sld xmlns:a="http://schemas.openxmlformats.org/drawingml/2006/main" xmlns:r="http://schemas.openxmlformats.org/officeDocument/2006/relationships" xmlns:p="http://schemas.openxmlformats.org/presentationml/2006/main">
   <p:cSld>
     <p:spTree>
@@ -4858,6 +4842,41 @@
           </a:p>
         </p:txBody>
       </p:sp>
+      <p:sp>
+        <p:nvSpPr>
+          <p:cNvPr id="4" name="TextBox 3">
+            <a:extLst>
+              <a:ext uri="{FF2B5EF4-FFF2-40B4-BE49-F238E27FC236}">
+                <a16:creationId xmlns:a16="http://schemas.microsoft.com/office/drawing/2014/main" id="{2D06E85B-57BB-5AF8-37C1-68A6D1DC12E2}"/>
+              </a:ext>
+            </a:extLst>
+          </p:cNvPr>
+          <p:cNvSpPr txBox="1"/>
+          <p:nvPr/>
+        </p:nvSpPr>
+        <p:spPr>
+          <a:xfrm>
+            <a:off x="9795318" y="6473388"/>
+            <a:ext cx="2396682" cy="369332"/>
+          </a:xfrm>
+          <a:prstGeom prst="rect">
+            <a:avLst/>
+          </a:prstGeom>
+          <a:noFill/>
+        </p:spPr>
+        <p:txBody>
+          <a:bodyPr wrap="none" rtlCol="0">
+            <a:spAutoFit/>
+          </a:bodyPr>
+          <a:lstStyle/>
+          <a:p>
+            <a:r>
+              <a:rPr lang="en-US" dirty="0"/>
+              <a:t>Perkowski et al. (2025)</a:t>
+            </a:r>
+          </a:p>
+        </p:txBody>
+      </p:sp>
     </p:spTree>
     <p:extLst>
       <p:ext uri="{BB962C8B-B14F-4D97-AF65-F5344CB8AC3E}">
@@ -4871,7 +4890,7 @@
 </p:sld>
 </file>
 
-<file path=ppt/slides/slide18.xml><?xml version="1.0" encoding="utf-8"?>
+<file path=ppt/slides/slide16.xml><?xml version="1.0" encoding="utf-8"?>
 <p:sld xmlns:a="http://schemas.openxmlformats.org/drawingml/2006/main" xmlns:r="http://schemas.openxmlformats.org/officeDocument/2006/relationships" xmlns:p="http://schemas.openxmlformats.org/presentationml/2006/main">
   <p:cSld>
     <p:spTree>
@@ -5032,6 +5051,41 @@
           </a:p>
         </p:txBody>
       </p:sp>
+      <p:sp>
+        <p:nvSpPr>
+          <p:cNvPr id="4" name="TextBox 3">
+            <a:extLst>
+              <a:ext uri="{FF2B5EF4-FFF2-40B4-BE49-F238E27FC236}">
+                <a16:creationId xmlns:a16="http://schemas.microsoft.com/office/drawing/2014/main" id="{77F0F3E1-9A78-F0DB-39C3-23C4B4C0FB8C}"/>
+              </a:ext>
+            </a:extLst>
+          </p:cNvPr>
+          <p:cNvSpPr txBox="1"/>
+          <p:nvPr/>
+        </p:nvSpPr>
+        <p:spPr>
+          <a:xfrm>
+            <a:off x="9795318" y="6473388"/>
+            <a:ext cx="2396682" cy="369332"/>
+          </a:xfrm>
+          <a:prstGeom prst="rect">
+            <a:avLst/>
+          </a:prstGeom>
+          <a:noFill/>
+        </p:spPr>
+        <p:txBody>
+          <a:bodyPr wrap="none" rtlCol="0">
+            <a:spAutoFit/>
+          </a:bodyPr>
+          <a:lstStyle/>
+          <a:p>
+            <a:r>
+              <a:rPr lang="en-US" dirty="0"/>
+              <a:t>Perkowski et al. (2025)</a:t>
+            </a:r>
+          </a:p>
+        </p:txBody>
+      </p:sp>
     </p:spTree>
     <p:extLst>
       <p:ext uri="{BB962C8B-B14F-4D97-AF65-F5344CB8AC3E}">
@@ -5045,7 +5099,241 @@
 </p:sld>
 </file>
 
-<file path=ppt/slides/slide19.xml><?xml version="1.0" encoding="utf-8"?>
+<file path=ppt/slides/slide17.xml><?xml version="1.0" encoding="utf-8"?>
+<p:sld xmlns:a="http://schemas.openxmlformats.org/drawingml/2006/main" xmlns:r="http://schemas.openxmlformats.org/officeDocument/2006/relationships" xmlns:p="http://schemas.openxmlformats.org/presentationml/2006/main">
+  <p:cSld>
+    <p:spTree>
+      <p:nvGrpSpPr>
+        <p:cNvPr id="1" name="">
+          <a:extLst>
+            <a:ext uri="{FF2B5EF4-FFF2-40B4-BE49-F238E27FC236}">
+              <a16:creationId xmlns:a16="http://schemas.microsoft.com/office/drawing/2014/main" id="{B702F14D-3E44-A81C-AFC8-B6B29095162A}"/>
+            </a:ext>
+          </a:extLst>
+        </p:cNvPr>
+        <p:cNvGrpSpPr/>
+        <p:nvPr/>
+      </p:nvGrpSpPr>
+      <p:grpSpPr>
+        <a:xfrm>
+          <a:off x="0" y="0"/>
+          <a:ext cx="0" cy="0"/>
+          <a:chOff x="0" y="0"/>
+          <a:chExt cx="0" cy="0"/>
+        </a:xfrm>
+      </p:grpSpPr>
+      <p:sp>
+        <p:nvSpPr>
+          <p:cNvPr id="2" name="Title 1">
+            <a:extLst>
+              <a:ext uri="{FF2B5EF4-FFF2-40B4-BE49-F238E27FC236}">
+                <a16:creationId xmlns:a16="http://schemas.microsoft.com/office/drawing/2014/main" id="{F9D8F231-04FB-AD97-077B-571A9FCA31A0}"/>
+              </a:ext>
+            </a:extLst>
+          </p:cNvPr>
+          <p:cNvSpPr>
+            <a:spLocks noGrp="1"/>
+          </p:cNvSpPr>
+          <p:nvPr>
+            <p:ph type="title"/>
+          </p:nvPr>
+        </p:nvSpPr>
+        <p:spPr/>
+        <p:txBody>
+          <a:bodyPr/>
+          <a:lstStyle/>
+          <a:p>
+            <a:r>
+              <a:rPr lang="en-US" dirty="0"/>
+              <a:t>Experiment 4: Light x Soil Phosphorus x C</a:t>
+            </a:r>
+            <a:r>
+              <a:rPr lang="en-US" baseline="-25000" dirty="0"/>
+              <a:t>3</a:t>
+            </a:r>
+            <a:r>
+              <a:rPr lang="en-US" dirty="0"/>
+              <a:t>/C</a:t>
+            </a:r>
+            <a:r>
+              <a:rPr lang="en-US" baseline="-25000" dirty="0"/>
+              <a:t>4</a:t>
+            </a:r>
+            <a:endParaRPr lang="en-US" dirty="0"/>
+          </a:p>
+        </p:txBody>
+      </p:sp>
+      <p:sp>
+        <p:nvSpPr>
+          <p:cNvPr id="3" name="Content Placeholder 2">
+            <a:extLst>
+              <a:ext uri="{FF2B5EF4-FFF2-40B4-BE49-F238E27FC236}">
+                <a16:creationId xmlns:a16="http://schemas.microsoft.com/office/drawing/2014/main" id="{E16B5F64-9285-21D1-ADD2-FB4CD0C8804C}"/>
+              </a:ext>
+            </a:extLst>
+          </p:cNvPr>
+          <p:cNvSpPr>
+            <a:spLocks noGrp="1"/>
+          </p:cNvSpPr>
+          <p:nvPr>
+            <p:ph idx="1"/>
+          </p:nvPr>
+        </p:nvSpPr>
+        <p:spPr/>
+        <p:txBody>
+          <a:bodyPr>
+            <a:normAutofit/>
+          </a:bodyPr>
+          <a:lstStyle/>
+          <a:p>
+            <a:r>
+              <a:rPr lang="en-US" dirty="0"/>
+              <a:t>Within leaves</a:t>
+            </a:r>
+          </a:p>
+          <a:p>
+            <a:pPr lvl="1"/>
+            <a:r>
+              <a:rPr lang="en-US" dirty="0">
+                <a:solidFill>
+                  <a:schemeClr val="bg1">
+                    <a:lumMod val="85000"/>
+                  </a:schemeClr>
+                </a:solidFill>
+              </a:rPr>
+              <a:t>Nitrogen allocation</a:t>
+            </a:r>
+          </a:p>
+          <a:p>
+            <a:pPr lvl="1"/>
+            <a:r>
+              <a:rPr lang="en-US" dirty="0">
+                <a:solidFill>
+                  <a:srgbClr val="002060"/>
+                </a:solidFill>
+              </a:rPr>
+              <a:t>Phosphorus allocation</a:t>
+            </a:r>
+          </a:p>
+          <a:p>
+            <a:r>
+              <a:rPr lang="en-US" dirty="0"/>
+              <a:t>Whole plant</a:t>
+            </a:r>
+          </a:p>
+          <a:p>
+            <a:pPr lvl="1"/>
+            <a:r>
+              <a:rPr lang="en-US" dirty="0" err="1">
+                <a:solidFill>
+                  <a:srgbClr val="002060"/>
+                </a:solidFill>
+              </a:rPr>
+              <a:t>Root:Shoot</a:t>
+            </a:r>
+            <a:r>
+              <a:rPr lang="en-US" dirty="0">
+                <a:solidFill>
+                  <a:srgbClr val="002060"/>
+                </a:solidFill>
+              </a:rPr>
+              <a:t> ratio</a:t>
+            </a:r>
+          </a:p>
+          <a:p>
+            <a:pPr lvl="1"/>
+            <a:r>
+              <a:rPr lang="en-US" dirty="0">
+                <a:solidFill>
+                  <a:schemeClr val="bg1">
+                    <a:lumMod val="85000"/>
+                  </a:schemeClr>
+                </a:solidFill>
+              </a:rPr>
+              <a:t>Total leaf area</a:t>
+            </a:r>
+          </a:p>
+        </p:txBody>
+      </p:sp>
+      <p:pic>
+        <p:nvPicPr>
+          <p:cNvPr id="4" name="Picture 3">
+            <a:extLst>
+              <a:ext uri="{FF2B5EF4-FFF2-40B4-BE49-F238E27FC236}">
+                <a16:creationId xmlns:a16="http://schemas.microsoft.com/office/drawing/2014/main" id="{183A612A-0267-8866-DB60-2AB7E470965A}"/>
+              </a:ext>
+            </a:extLst>
+          </p:cNvPr>
+          <p:cNvPicPr>
+            <a:picLocks noChangeAspect="1"/>
+          </p:cNvPicPr>
+          <p:nvPr/>
+        </p:nvPicPr>
+        <p:blipFill>
+          <a:blip r:embed="rId2"/>
+          <a:stretch>
+            <a:fillRect/>
+          </a:stretch>
+        </p:blipFill>
+        <p:spPr>
+          <a:xfrm>
+            <a:off x="7817069" y="2837794"/>
+            <a:ext cx="2475186" cy="2475186"/>
+          </a:xfrm>
+          <a:prstGeom prst="rect">
+            <a:avLst/>
+          </a:prstGeom>
+        </p:spPr>
+      </p:pic>
+      <p:sp>
+        <p:nvSpPr>
+          <p:cNvPr id="5" name="TextBox 4">
+            <a:extLst>
+              <a:ext uri="{FF2B5EF4-FFF2-40B4-BE49-F238E27FC236}">
+                <a16:creationId xmlns:a16="http://schemas.microsoft.com/office/drawing/2014/main" id="{913FAD88-39B6-238C-3451-C356366CBB16}"/>
+              </a:ext>
+            </a:extLst>
+          </p:cNvPr>
+          <p:cNvSpPr txBox="1"/>
+          <p:nvPr/>
+        </p:nvSpPr>
+        <p:spPr>
+          <a:xfrm>
+            <a:off x="10011275" y="6492875"/>
+            <a:ext cx="2180725" cy="369332"/>
+          </a:xfrm>
+          <a:prstGeom prst="rect">
+            <a:avLst/>
+          </a:prstGeom>
+          <a:noFill/>
+        </p:spPr>
+        <p:txBody>
+          <a:bodyPr wrap="none" rtlCol="0">
+            <a:spAutoFit/>
+          </a:bodyPr>
+          <a:lstStyle/>
+          <a:p>
+            <a:r>
+              <a:rPr lang="en-US" dirty="0"/>
+              <a:t>Kelley et al. (in prep)</a:t>
+            </a:r>
+          </a:p>
+        </p:txBody>
+      </p:sp>
+    </p:spTree>
+    <p:extLst>
+      <p:ext uri="{BB962C8B-B14F-4D97-AF65-F5344CB8AC3E}">
+        <p14:creationId xmlns:p14="http://schemas.microsoft.com/office/powerpoint/2010/main" val="903195904"/>
+      </p:ext>
+    </p:extLst>
+  </p:cSld>
+  <p:clrMapOvr>
+    <a:masterClrMapping/>
+  </p:clrMapOvr>
+</p:sld>
+</file>
+
+<file path=ppt/slides/slide18.xml><?xml version="1.0" encoding="utf-8"?>
 <p:sld xmlns:a="http://schemas.openxmlformats.org/drawingml/2006/main" xmlns:r="http://schemas.openxmlformats.org/officeDocument/2006/relationships" xmlns:p="http://schemas.openxmlformats.org/presentationml/2006/main">
   <p:cSld>
     <p:spTree>
@@ -5163,32 +5451,6 @@
           </a:p>
           <a:p>
             <a:r>
-              <a:rPr lang="en-US" dirty="0"/>
-              <a:t>Whole plant</a:t>
-            </a:r>
-          </a:p>
-          <a:p>
-            <a:pPr lvl="1"/>
-            <a:r>
-              <a:rPr lang="en-US" dirty="0" err="1">
-                <a:solidFill>
-                  <a:srgbClr val="002060"/>
-                </a:solidFill>
-              </a:rPr>
-              <a:t>Root:Shoot</a:t>
-            </a:r>
-            <a:r>
-              <a:rPr lang="en-US" dirty="0">
-                <a:solidFill>
-                  <a:srgbClr val="002060"/>
-                </a:solidFill>
-              </a:rPr>
-              <a:t> ratio</a:t>
-            </a:r>
-          </a:p>
-          <a:p>
-            <a:pPr lvl="1"/>
-            <a:r>
               <a:rPr lang="en-US" dirty="0">
                 <a:solidFill>
                   <a:schemeClr val="bg1">
@@ -5196,7 +5458,117 @@
                   </a:schemeClr>
                 </a:solidFill>
               </a:rPr>
+              <a:t>Whole plant</a:t>
+            </a:r>
+          </a:p>
+          <a:p>
+            <a:pPr lvl="1"/>
+            <a:r>
+              <a:rPr lang="en-US" dirty="0" err="1">
+                <a:solidFill>
+                  <a:schemeClr val="bg1">
+                    <a:lumMod val="85000"/>
+                  </a:schemeClr>
+                </a:solidFill>
+              </a:rPr>
+              <a:t>Root:Shoot</a:t>
+            </a:r>
+            <a:r>
+              <a:rPr lang="en-US" dirty="0">
+                <a:solidFill>
+                  <a:schemeClr val="bg1">
+                    <a:lumMod val="85000"/>
+                  </a:schemeClr>
+                </a:solidFill>
+              </a:rPr>
+              <a:t> ratio</a:t>
+            </a:r>
+          </a:p>
+          <a:p>
+            <a:pPr lvl="1"/>
+            <a:r>
+              <a:rPr lang="en-US" dirty="0">
+                <a:solidFill>
+                  <a:schemeClr val="bg1">
+                    <a:lumMod val="85000"/>
+                  </a:schemeClr>
+                </a:solidFill>
+              </a:rPr>
               <a:t>Total leaf area</a:t>
+            </a:r>
+          </a:p>
+        </p:txBody>
+      </p:sp>
+      <p:sp>
+        <p:nvSpPr>
+          <p:cNvPr id="4" name="TextBox 3">
+            <a:extLst>
+              <a:ext uri="{FF2B5EF4-FFF2-40B4-BE49-F238E27FC236}">
+                <a16:creationId xmlns:a16="http://schemas.microsoft.com/office/drawing/2014/main" id="{5AD45674-5BE0-7CE3-CFF1-BADC772AE9E3}"/>
+              </a:ext>
+            </a:extLst>
+          </p:cNvPr>
+          <p:cNvSpPr txBox="1"/>
+          <p:nvPr/>
+        </p:nvSpPr>
+        <p:spPr>
+          <a:xfrm>
+            <a:off x="4456386" y="3926252"/>
+            <a:ext cx="7537063" cy="523220"/>
+          </a:xfrm>
+          <a:prstGeom prst="rect">
+            <a:avLst/>
+          </a:prstGeom>
+          <a:noFill/>
+        </p:spPr>
+        <p:txBody>
+          <a:bodyPr wrap="none" rtlCol="0">
+            <a:spAutoFit/>
+          </a:bodyPr>
+          <a:lstStyle/>
+          <a:p>
+            <a:r>
+              <a:rPr lang="en-US" sz="2800" dirty="0">
+                <a:solidFill>
+                  <a:srgbClr val="FF0000"/>
+                </a:solidFill>
+              </a:rPr>
+              <a:t>Digestion system in place; results coming soon!</a:t>
+            </a:r>
+          </a:p>
+        </p:txBody>
+      </p:sp>
+      <p:sp>
+        <p:nvSpPr>
+          <p:cNvPr id="5" name="TextBox 4">
+            <a:extLst>
+              <a:ext uri="{FF2B5EF4-FFF2-40B4-BE49-F238E27FC236}">
+                <a16:creationId xmlns:a16="http://schemas.microsoft.com/office/drawing/2014/main" id="{78AF9382-63DC-CAD7-0A2E-0949D5D9FE36}"/>
+              </a:ext>
+            </a:extLst>
+          </p:cNvPr>
+          <p:cNvSpPr txBox="1"/>
+          <p:nvPr/>
+        </p:nvSpPr>
+        <p:spPr>
+          <a:xfrm>
+            <a:off x="10011275" y="6492875"/>
+            <a:ext cx="2180725" cy="369332"/>
+          </a:xfrm>
+          <a:prstGeom prst="rect">
+            <a:avLst/>
+          </a:prstGeom>
+          <a:noFill/>
+        </p:spPr>
+        <p:txBody>
+          <a:bodyPr wrap="none" rtlCol="0">
+            <a:spAutoFit/>
+          </a:bodyPr>
+          <a:lstStyle/>
+          <a:p>
+            <a:r>
+              <a:rPr lang="en-US" dirty="0"/>
+              <a:t>Kelley et al. (in prep)</a:t>
             </a:r>
           </a:p>
         </p:txBody>
@@ -5205,6 +5577,297 @@
     <p:extLst>
       <p:ext uri="{BB962C8B-B14F-4D97-AF65-F5344CB8AC3E}">
         <p14:creationId xmlns:p14="http://schemas.microsoft.com/office/powerpoint/2010/main" val="161505425"/>
+      </p:ext>
+    </p:extLst>
+  </p:cSld>
+  <p:clrMapOvr>
+    <a:masterClrMapping/>
+  </p:clrMapOvr>
+</p:sld>
+</file>
+
+<file path=ppt/slides/slide19.xml><?xml version="1.0" encoding="utf-8"?>
+<p:sld xmlns:a="http://schemas.openxmlformats.org/drawingml/2006/main" xmlns:r="http://schemas.openxmlformats.org/officeDocument/2006/relationships" xmlns:p="http://schemas.openxmlformats.org/presentationml/2006/main">
+  <p:cSld>
+    <p:spTree>
+      <p:nvGrpSpPr>
+        <p:cNvPr id="1" name="">
+          <a:extLst>
+            <a:ext uri="{FF2B5EF4-FFF2-40B4-BE49-F238E27FC236}">
+              <a16:creationId xmlns:a16="http://schemas.microsoft.com/office/drawing/2014/main" id="{D0C1E685-0B31-5A85-50EB-3E56FC66AD89}"/>
+            </a:ext>
+          </a:extLst>
+        </p:cNvPr>
+        <p:cNvGrpSpPr/>
+        <p:nvPr/>
+      </p:nvGrpSpPr>
+      <p:grpSpPr>
+        <a:xfrm>
+          <a:off x="0" y="0"/>
+          <a:ext cx="0" cy="0"/>
+          <a:chOff x="0" y="0"/>
+          <a:chExt cx="0" cy="0"/>
+        </a:xfrm>
+      </p:grpSpPr>
+      <p:sp>
+        <p:nvSpPr>
+          <p:cNvPr id="2" name="Title 1">
+            <a:extLst>
+              <a:ext uri="{FF2B5EF4-FFF2-40B4-BE49-F238E27FC236}">
+                <a16:creationId xmlns:a16="http://schemas.microsoft.com/office/drawing/2014/main" id="{AB0A14CF-2E51-DBE7-24DC-E31397CCD9F7}"/>
+              </a:ext>
+            </a:extLst>
+          </p:cNvPr>
+          <p:cNvSpPr>
+            <a:spLocks noGrp="1"/>
+          </p:cNvSpPr>
+          <p:nvPr>
+            <p:ph type="title"/>
+          </p:nvPr>
+        </p:nvSpPr>
+        <p:spPr/>
+        <p:txBody>
+          <a:bodyPr/>
+          <a:lstStyle/>
+          <a:p>
+            <a:r>
+              <a:rPr lang="en-US" dirty="0"/>
+              <a:t>Experiment 4: Light x Soil Phosphorus x C</a:t>
+            </a:r>
+            <a:r>
+              <a:rPr lang="en-US" baseline="-25000" dirty="0"/>
+              <a:t>3</a:t>
+            </a:r>
+            <a:r>
+              <a:rPr lang="en-US" dirty="0"/>
+              <a:t>/C</a:t>
+            </a:r>
+            <a:r>
+              <a:rPr lang="en-US" baseline="-25000" dirty="0"/>
+              <a:t>4</a:t>
+            </a:r>
+            <a:endParaRPr lang="en-US" dirty="0"/>
+          </a:p>
+        </p:txBody>
+      </p:sp>
+      <p:sp>
+        <p:nvSpPr>
+          <p:cNvPr id="3" name="Content Placeholder 2">
+            <a:extLst>
+              <a:ext uri="{FF2B5EF4-FFF2-40B4-BE49-F238E27FC236}">
+                <a16:creationId xmlns:a16="http://schemas.microsoft.com/office/drawing/2014/main" id="{A9068B6B-9B07-04F0-9D71-9F7F22F5E234}"/>
+              </a:ext>
+            </a:extLst>
+          </p:cNvPr>
+          <p:cNvSpPr>
+            <a:spLocks noGrp="1"/>
+          </p:cNvSpPr>
+          <p:nvPr>
+            <p:ph idx="1"/>
+          </p:nvPr>
+        </p:nvSpPr>
+        <p:spPr/>
+        <p:txBody>
+          <a:bodyPr>
+            <a:normAutofit/>
+          </a:bodyPr>
+          <a:lstStyle/>
+          <a:p>
+            <a:r>
+              <a:rPr lang="en-US" dirty="0">
+                <a:solidFill>
+                  <a:schemeClr val="bg1">
+                    <a:lumMod val="85000"/>
+                  </a:schemeClr>
+                </a:solidFill>
+              </a:rPr>
+              <a:t>Within leaves</a:t>
+            </a:r>
+          </a:p>
+          <a:p>
+            <a:pPr lvl="1"/>
+            <a:r>
+              <a:rPr lang="en-US" dirty="0">
+                <a:solidFill>
+                  <a:schemeClr val="bg1">
+                    <a:lumMod val="85000"/>
+                  </a:schemeClr>
+                </a:solidFill>
+              </a:rPr>
+              <a:t>Nitrogen allocation</a:t>
+            </a:r>
+          </a:p>
+          <a:p>
+            <a:pPr lvl="1"/>
+            <a:r>
+              <a:rPr lang="en-US" dirty="0">
+                <a:solidFill>
+                  <a:schemeClr val="bg1">
+                    <a:lumMod val="85000"/>
+                  </a:schemeClr>
+                </a:solidFill>
+              </a:rPr>
+              <a:t>Phosphorus allocation</a:t>
+            </a:r>
+          </a:p>
+          <a:p>
+            <a:r>
+              <a:rPr lang="en-US" dirty="0"/>
+              <a:t>Whole plant</a:t>
+            </a:r>
+          </a:p>
+          <a:p>
+            <a:pPr lvl="1"/>
+            <a:r>
+              <a:rPr lang="en-US" dirty="0" err="1">
+                <a:solidFill>
+                  <a:srgbClr val="002060"/>
+                </a:solidFill>
+              </a:rPr>
+              <a:t>Root:Shoot</a:t>
+            </a:r>
+            <a:r>
+              <a:rPr lang="en-US" dirty="0">
+                <a:solidFill>
+                  <a:srgbClr val="002060"/>
+                </a:solidFill>
+              </a:rPr>
+              <a:t> ratio</a:t>
+            </a:r>
+          </a:p>
+          <a:p>
+            <a:pPr lvl="1"/>
+            <a:r>
+              <a:rPr lang="en-US" dirty="0">
+                <a:solidFill>
+                  <a:schemeClr val="bg1">
+                    <a:lumMod val="85000"/>
+                  </a:schemeClr>
+                </a:solidFill>
+              </a:rPr>
+              <a:t>Total leaf area</a:t>
+            </a:r>
+          </a:p>
+        </p:txBody>
+      </p:sp>
+      <p:pic>
+        <p:nvPicPr>
+          <p:cNvPr id="4" name="Picture 3">
+            <a:extLst>
+              <a:ext uri="{FF2B5EF4-FFF2-40B4-BE49-F238E27FC236}">
+                <a16:creationId xmlns:a16="http://schemas.microsoft.com/office/drawing/2014/main" id="{880B6CEF-CDA7-697B-BDE7-415D1A87C357}"/>
+              </a:ext>
+            </a:extLst>
+          </p:cNvPr>
+          <p:cNvPicPr>
+            <a:picLocks noChangeAspect="1"/>
+          </p:cNvPicPr>
+          <p:nvPr/>
+        </p:nvPicPr>
+        <p:blipFill>
+          <a:blip r:embed="rId2"/>
+          <a:stretch>
+            <a:fillRect/>
+          </a:stretch>
+        </p:blipFill>
+        <p:spPr>
+          <a:xfrm>
+            <a:off x="5739114" y="1740092"/>
+            <a:ext cx="4981437" cy="4429696"/>
+          </a:xfrm>
+          <a:prstGeom prst="rect">
+            <a:avLst/>
+          </a:prstGeom>
+        </p:spPr>
+      </p:pic>
+      <p:sp>
+        <p:nvSpPr>
+          <p:cNvPr id="5" name="TextBox 4">
+            <a:extLst>
+              <a:ext uri="{FF2B5EF4-FFF2-40B4-BE49-F238E27FC236}">
+                <a16:creationId xmlns:a16="http://schemas.microsoft.com/office/drawing/2014/main" id="{3EA99183-2E21-AC08-5200-9E33085D7FA2}"/>
+              </a:ext>
+            </a:extLst>
+          </p:cNvPr>
+          <p:cNvSpPr txBox="1"/>
+          <p:nvPr/>
+        </p:nvSpPr>
+        <p:spPr>
+          <a:xfrm>
+            <a:off x="662152" y="4750676"/>
+            <a:ext cx="4227568" cy="1200329"/>
+          </a:xfrm>
+          <a:prstGeom prst="rect">
+            <a:avLst/>
+          </a:prstGeom>
+          <a:noFill/>
+        </p:spPr>
+        <p:txBody>
+          <a:bodyPr wrap="none" rtlCol="0">
+            <a:spAutoFit/>
+          </a:bodyPr>
+          <a:lstStyle/>
+          <a:p>
+            <a:r>
+              <a:rPr lang="en-US" sz="3600" dirty="0">
+                <a:solidFill>
+                  <a:srgbClr val="FF0000"/>
+                </a:solidFill>
+              </a:rPr>
+              <a:t>Light increases R:S</a:t>
+            </a:r>
+          </a:p>
+          <a:p>
+            <a:r>
+              <a:rPr lang="en-US" sz="3600" dirty="0">
+                <a:solidFill>
+                  <a:srgbClr val="FF0000"/>
+                </a:solidFill>
+              </a:rPr>
+              <a:t>Soil P decreases R:S</a:t>
+            </a:r>
+          </a:p>
+        </p:txBody>
+      </p:sp>
+      <p:sp>
+        <p:nvSpPr>
+          <p:cNvPr id="6" name="TextBox 5">
+            <a:extLst>
+              <a:ext uri="{FF2B5EF4-FFF2-40B4-BE49-F238E27FC236}">
+                <a16:creationId xmlns:a16="http://schemas.microsoft.com/office/drawing/2014/main" id="{D007461A-EB0A-47B0-B571-BFE12E6492A8}"/>
+              </a:ext>
+            </a:extLst>
+          </p:cNvPr>
+          <p:cNvSpPr txBox="1"/>
+          <p:nvPr/>
+        </p:nvSpPr>
+        <p:spPr>
+          <a:xfrm>
+            <a:off x="10011275" y="6492875"/>
+            <a:ext cx="2180725" cy="369332"/>
+          </a:xfrm>
+          <a:prstGeom prst="rect">
+            <a:avLst/>
+          </a:prstGeom>
+          <a:noFill/>
+        </p:spPr>
+        <p:txBody>
+          <a:bodyPr wrap="none" rtlCol="0">
+            <a:spAutoFit/>
+          </a:bodyPr>
+          <a:lstStyle/>
+          <a:p>
+            <a:r>
+              <a:rPr lang="en-US" dirty="0"/>
+              <a:t>Kelley et al. (in prep)</a:t>
+            </a:r>
+          </a:p>
+        </p:txBody>
+      </p:sp>
+    </p:spTree>
+    <p:extLst>
+      <p:ext uri="{BB962C8B-B14F-4D97-AF65-F5344CB8AC3E}">
+        <p14:creationId xmlns:p14="http://schemas.microsoft.com/office/powerpoint/2010/main" val="1815406777"/>
       </p:ext>
     </p:extLst>
   </p:cSld>
@@ -6148,7 +6811,7 @@
         <p:cNvPr id="1" name="">
           <a:extLst>
             <a:ext uri="{FF2B5EF4-FFF2-40B4-BE49-F238E27FC236}">
-              <a16:creationId xmlns:a16="http://schemas.microsoft.com/office/drawing/2014/main" id="{814E3A8B-672C-620A-428E-EB7772F647AE}"/>
+              <a16:creationId xmlns:a16="http://schemas.microsoft.com/office/drawing/2014/main" id="{081F4B8E-FFCB-C7E4-912F-E1E7B83742CF}"/>
             </a:ext>
           </a:extLst>
         </p:cNvPr>
@@ -6168,7 +6831,7 @@
           <p:cNvPr id="2" name="Title 1">
             <a:extLst>
               <a:ext uri="{FF2B5EF4-FFF2-40B4-BE49-F238E27FC236}">
-                <a16:creationId xmlns:a16="http://schemas.microsoft.com/office/drawing/2014/main" id="{709B3258-5FE9-70F0-F8D3-A57F7B2CB5D1}"/>
+                <a16:creationId xmlns:a16="http://schemas.microsoft.com/office/drawing/2014/main" id="{C4E0AF7A-3584-14C5-8D91-8E04A4C1F06C}"/>
               </a:ext>
             </a:extLst>
           </p:cNvPr>
@@ -6186,7 +6849,7 @@
           <a:p>
             <a:r>
               <a:rPr lang="en-US" dirty="0"/>
-              <a:t>General approach to measuring allocation in experiments</a:t>
+              <a:t>Experiment 1: Light x Soil Nitrogen x N-fixation</a:t>
             </a:r>
           </a:p>
         </p:txBody>
@@ -6196,7 +6859,7 @@
           <p:cNvPr id="3" name="Content Placeholder 2">
             <a:extLst>
               <a:ext uri="{FF2B5EF4-FFF2-40B4-BE49-F238E27FC236}">
-                <a16:creationId xmlns:a16="http://schemas.microsoft.com/office/drawing/2014/main" id="{78B19B0A-EE32-18BC-5278-F0EADF76B384}"/>
+                <a16:creationId xmlns:a16="http://schemas.microsoft.com/office/drawing/2014/main" id="{F41BEB87-60E9-D1AD-502B-EBF94F330296}"/>
               </a:ext>
             </a:extLst>
           </p:cNvPr>
@@ -6215,6 +6878,24 @@
           <a:lstStyle/>
           <a:p>
             <a:r>
+              <a:rPr lang="en-US" dirty="0"/>
+              <a:t>Within leaves</a:t>
+            </a:r>
+          </a:p>
+          <a:p>
+            <a:pPr lvl="1"/>
+            <a:r>
+              <a:rPr lang="en-US" dirty="0">
+                <a:solidFill>
+                  <a:srgbClr val="002060"/>
+                </a:solidFill>
+              </a:rPr>
+              <a:t>Nitrogen allocation</a:t>
+            </a:r>
+          </a:p>
+          <a:p>
+            <a:pPr lvl="1"/>
+            <a:r>
               <a:rPr lang="en-US" dirty="0">
                 <a:solidFill>
                   <a:schemeClr val="bg1">
@@ -6222,20 +6903,32 @@
                   </a:schemeClr>
                 </a:solidFill>
               </a:rPr>
-              <a:t>Within leaves</a:t>
+              <a:t>Phosphorus allocation</a:t>
+            </a:r>
+          </a:p>
+          <a:p>
+            <a:r>
+              <a:rPr lang="en-US" dirty="0"/>
+              <a:t>Whole plant</a:t>
             </a:r>
           </a:p>
           <a:p>
             <a:pPr lvl="1"/>
             <a:r>
+              <a:rPr lang="en-US" dirty="0" err="1">
+                <a:solidFill>
+                  <a:srgbClr val="002060"/>
+                </a:solidFill>
+              </a:rPr>
+              <a:t>Root:Shoot</a:t>
+            </a:r>
+            <a:r>
               <a:rPr lang="en-US" dirty="0">
                 <a:solidFill>
-                  <a:schemeClr val="bg1">
-                    <a:lumMod val="85000"/>
-                  </a:schemeClr>
-                </a:solidFill>
-              </a:rPr>
-              <a:t>Nitrogen allocation</a:t>
+                  <a:srgbClr val="002060"/>
+                </a:solidFill>
+              </a:rPr>
+              <a:t> ratio</a:t>
             </a:r>
           </a:p>
           <a:p>
@@ -6243,63 +6936,117 @@
             <a:r>
               <a:rPr lang="en-US" dirty="0">
                 <a:solidFill>
-                  <a:schemeClr val="bg1">
-                    <a:lumMod val="85000"/>
-                  </a:schemeClr>
-                </a:solidFill>
-              </a:rPr>
-              <a:t>Phosphorus allocation</a:t>
-            </a:r>
-          </a:p>
-          <a:p>
-            <a:r>
-              <a:rPr lang="en-US" dirty="0"/>
-              <a:t>Whole plant</a:t>
-            </a:r>
-          </a:p>
-          <a:p>
-            <a:pPr lvl="1"/>
-            <a:r>
-              <a:rPr lang="en-US" dirty="0" err="1"/>
-              <a:t>Root:Shoot</a:t>
-            </a:r>
-            <a:r>
-              <a:rPr lang="en-US" dirty="0"/>
-              <a:t> ratio</a:t>
-            </a:r>
-          </a:p>
-          <a:p>
-            <a:pPr lvl="2"/>
-            <a:r>
-              <a:rPr lang="en-US" dirty="0"/>
-              <a:t>Leaves</a:t>
-            </a:r>
-          </a:p>
-          <a:p>
-            <a:pPr lvl="2"/>
-            <a:r>
-              <a:rPr lang="en-US" dirty="0"/>
-              <a:t>Stems</a:t>
-            </a:r>
-          </a:p>
-          <a:p>
-            <a:pPr lvl="2"/>
-            <a:r>
-              <a:rPr lang="en-US" dirty="0"/>
-              <a:t>Roots</a:t>
-            </a:r>
-          </a:p>
-          <a:p>
-            <a:pPr lvl="1"/>
-            <a:r>
-              <a:rPr lang="en-US" dirty="0">
-                <a:solidFill>
-                  <a:schemeClr val="bg1">
-                    <a:lumMod val="85000"/>
-                  </a:schemeClr>
+                  <a:srgbClr val="002060"/>
                 </a:solidFill>
               </a:rPr>
               <a:t>Total leaf area</a:t>
+            </a:r>
+          </a:p>
+        </p:txBody>
+      </p:sp>
+      <p:pic>
+        <p:nvPicPr>
+          <p:cNvPr id="4" name="Picture 3">
+            <a:extLst>
+              <a:ext uri="{FF2B5EF4-FFF2-40B4-BE49-F238E27FC236}">
+                <a16:creationId xmlns:a16="http://schemas.microsoft.com/office/drawing/2014/main" id="{ABABCA28-74CF-5DAD-F7A4-8926384404A4}"/>
+              </a:ext>
+            </a:extLst>
+          </p:cNvPr>
+          <p:cNvPicPr>
+            <a:picLocks noChangeAspect="1"/>
+          </p:cNvPicPr>
+          <p:nvPr/>
+        </p:nvPicPr>
+        <p:blipFill>
+          <a:blip r:embed="rId2" cstate="print">
+            <a:extLst>
+              <a:ext uri="{28A0092B-C50C-407E-A947-70E740481C1C}">
+                <a14:useLocalDpi xmlns:a14="http://schemas.microsoft.com/office/drawing/2010/main"/>
+              </a:ext>
+            </a:extLst>
+          </a:blip>
+          <a:stretch>
+            <a:fillRect/>
+          </a:stretch>
+        </p:blipFill>
+        <p:spPr>
+          <a:xfrm>
+            <a:off x="6543394" y="1852745"/>
+            <a:ext cx="2399684" cy="2397410"/>
+          </a:xfrm>
+          <a:prstGeom prst="rect">
+            <a:avLst/>
+          </a:prstGeom>
+        </p:spPr>
+      </p:pic>
+      <p:pic>
+        <p:nvPicPr>
+          <p:cNvPr id="5" name="Picture 4">
+            <a:extLst>
+              <a:ext uri="{FF2B5EF4-FFF2-40B4-BE49-F238E27FC236}">
+                <a16:creationId xmlns:a16="http://schemas.microsoft.com/office/drawing/2014/main" id="{F98F5CE5-3DB2-C8E9-F11A-5DB9FB8CE6ED}"/>
+              </a:ext>
+            </a:extLst>
+          </p:cNvPr>
+          <p:cNvPicPr>
+            <a:picLocks noChangeAspect="1"/>
+          </p:cNvPicPr>
+          <p:nvPr/>
+        </p:nvPicPr>
+        <p:blipFill>
+          <a:blip r:embed="rId3" cstate="hqprint">
+            <a:extLst>
+              <a:ext uri="{28A0092B-C50C-407E-A947-70E740481C1C}">
+                <a14:useLocalDpi xmlns:a14="http://schemas.microsoft.com/office/drawing/2010/main"/>
+              </a:ext>
+            </a:extLst>
+          </a:blip>
+          <a:stretch>
+            <a:fillRect/>
+          </a:stretch>
+        </p:blipFill>
+        <p:spPr>
+          <a:xfrm>
+            <a:off x="9295214" y="3535451"/>
+            <a:ext cx="2641512" cy="2641512"/>
+          </a:xfrm>
+          <a:prstGeom prst="rect">
+            <a:avLst/>
+          </a:prstGeom>
+        </p:spPr>
+      </p:pic>
+      <p:sp>
+        <p:nvSpPr>
+          <p:cNvPr id="6" name="TextBox 5">
+            <a:extLst>
+              <a:ext uri="{FF2B5EF4-FFF2-40B4-BE49-F238E27FC236}">
+                <a16:creationId xmlns:a16="http://schemas.microsoft.com/office/drawing/2014/main" id="{AF2CE532-E5F9-E500-ADA1-A9040593FB80}"/>
+              </a:ext>
+            </a:extLst>
+          </p:cNvPr>
+          <p:cNvSpPr txBox="1"/>
+          <p:nvPr/>
+        </p:nvSpPr>
+        <p:spPr>
+          <a:xfrm>
+            <a:off x="5575104" y="6492875"/>
+            <a:ext cx="6735947" cy="369332"/>
+          </a:xfrm>
+          <a:prstGeom prst="rect">
+            <a:avLst/>
+          </a:prstGeom>
+          <a:noFill/>
+        </p:spPr>
+        <p:txBody>
+          <a:bodyPr wrap="none" rtlCol="0">
+            <a:spAutoFit/>
+          </a:bodyPr>
+          <a:lstStyle/>
+          <a:p>
+            <a:r>
+              <a:rPr lang="en-US" dirty="0"/>
+              <a:t>Perkowski et al. (2021), Waring et al. (2023), Perkowski et al. (2024)</a:t>
             </a:r>
           </a:p>
         </p:txBody>
@@ -6307,7 +7054,7 @@
     </p:spTree>
     <p:extLst>
       <p:ext uri="{BB962C8B-B14F-4D97-AF65-F5344CB8AC3E}">
-        <p14:creationId xmlns:p14="http://schemas.microsoft.com/office/powerpoint/2010/main" val="3349777398"/>
+        <p14:creationId xmlns:p14="http://schemas.microsoft.com/office/powerpoint/2010/main" val="2180978967"/>
       </p:ext>
     </p:extLst>
   </p:cSld>
@@ -6325,7 +7072,7 @@
         <p:cNvPr id="1" name="">
           <a:extLst>
             <a:ext uri="{FF2B5EF4-FFF2-40B4-BE49-F238E27FC236}">
-              <a16:creationId xmlns:a16="http://schemas.microsoft.com/office/drawing/2014/main" id="{D6DC543C-1F14-DC91-3A39-A77384567FB5}"/>
+              <a16:creationId xmlns:a16="http://schemas.microsoft.com/office/drawing/2014/main" id="{2B3C35B5-F04B-6C9F-52D1-F3C6AD3D6B98}"/>
             </a:ext>
           </a:extLst>
         </p:cNvPr>
@@ -6345,7 +7092,7 @@
           <p:cNvPr id="2" name="Title 1">
             <a:extLst>
               <a:ext uri="{FF2B5EF4-FFF2-40B4-BE49-F238E27FC236}">
-                <a16:creationId xmlns:a16="http://schemas.microsoft.com/office/drawing/2014/main" id="{B5D047A5-8649-5873-C9A4-40C63D28CF8A}"/>
+                <a16:creationId xmlns:a16="http://schemas.microsoft.com/office/drawing/2014/main" id="{49A87D41-9FE2-9D5A-203F-D1213E8F606C}"/>
               </a:ext>
             </a:extLst>
           </p:cNvPr>
@@ -6363,7 +7110,7 @@
           <a:p>
             <a:r>
               <a:rPr lang="en-US" dirty="0"/>
-              <a:t>General approach to measuring allocation in experiments</a:t>
+              <a:t>Experiment 1: Light x Soil Nitrogen x N-fixation</a:t>
             </a:r>
           </a:p>
         </p:txBody>
@@ -6373,7 +7120,7 @@
           <p:cNvPr id="3" name="Content Placeholder 2">
             <a:extLst>
               <a:ext uri="{FF2B5EF4-FFF2-40B4-BE49-F238E27FC236}">
-                <a16:creationId xmlns:a16="http://schemas.microsoft.com/office/drawing/2014/main" id="{F2F27290-A96B-DC2E-923E-E9A3E97AB2D3}"/>
+                <a16:creationId xmlns:a16="http://schemas.microsoft.com/office/drawing/2014/main" id="{27F9FF13-E5CF-A6B8-A870-69D4C81F1D71}"/>
               </a:ext>
             </a:extLst>
           </p:cNvPr>
@@ -6384,7 +7131,12 @@
             <p:ph idx="1"/>
           </p:nvPr>
         </p:nvSpPr>
-        <p:spPr/>
+        <p:spPr>
+          <a:xfrm>
+            <a:off x="838200" y="1825625"/>
+            <a:ext cx="5257800" cy="4351338"/>
+          </a:xfrm>
+        </p:spPr>
         <p:txBody>
           <a:bodyPr>
             <a:normAutofit/>
@@ -6407,16 +7159,26 @@
             <a:r>
               <a:rPr lang="en-US" dirty="0">
                 <a:solidFill>
+                  <a:srgbClr val="002060"/>
+                </a:solidFill>
+              </a:rPr>
+              <a:t>Nitrogen allocation</a:t>
+            </a:r>
+          </a:p>
+          <a:p>
+            <a:pPr lvl="1"/>
+            <a:r>
+              <a:rPr lang="en-US" dirty="0">
+                <a:solidFill>
                   <a:schemeClr val="bg1">
                     <a:lumMod val="85000"/>
                   </a:schemeClr>
                 </a:solidFill>
               </a:rPr>
-              <a:t>Nitrogen allocation</a:t>
-            </a:r>
-          </a:p>
-          <a:p>
-            <a:pPr lvl="1"/>
+              <a:t>Phosphorus allocation</a:t>
+            </a:r>
+          </a:p>
+          <a:p>
             <a:r>
               <a:rPr lang="en-US" dirty="0">
                 <a:solidFill>
@@ -6425,12 +7187,6 @@
                   </a:schemeClr>
                 </a:solidFill>
               </a:rPr>
-              <a:t>Phosphorus allocation</a:t>
-            </a:r>
-          </a:p>
-          <a:p>
-            <a:r>
-              <a:rPr lang="en-US" dirty="0"/>
               <a:t>Whole plant</a:t>
             </a:r>
           </a:p>
@@ -6460,8 +7216,116 @@
           <a:p>
             <a:pPr lvl="1"/>
             <a:r>
-              <a:rPr lang="en-US" dirty="0"/>
+              <a:rPr lang="en-US" dirty="0">
+                <a:solidFill>
+                  <a:schemeClr val="bg1">
+                    <a:lumMod val="85000"/>
+                  </a:schemeClr>
+                </a:solidFill>
+              </a:rPr>
               <a:t>Total leaf area</a:t>
+            </a:r>
+          </a:p>
+        </p:txBody>
+      </p:sp>
+      <p:sp>
+        <p:nvSpPr>
+          <p:cNvPr id="4" name="TextBox 3">
+            <a:extLst>
+              <a:ext uri="{FF2B5EF4-FFF2-40B4-BE49-F238E27FC236}">
+                <a16:creationId xmlns:a16="http://schemas.microsoft.com/office/drawing/2014/main" id="{AD4CE84B-4FC8-1B3D-7DAB-153060C0C815}"/>
+              </a:ext>
+            </a:extLst>
+          </p:cNvPr>
+          <p:cNvSpPr txBox="1"/>
+          <p:nvPr/>
+        </p:nvSpPr>
+        <p:spPr>
+          <a:xfrm>
+            <a:off x="838199" y="4731488"/>
+            <a:ext cx="5257801" cy="830997"/>
+          </a:xfrm>
+          <a:prstGeom prst="rect">
+            <a:avLst/>
+          </a:prstGeom>
+          <a:noFill/>
+        </p:spPr>
+        <p:txBody>
+          <a:bodyPr wrap="square" rtlCol="0">
+            <a:spAutoFit/>
+          </a:bodyPr>
+          <a:lstStyle/>
+          <a:p>
+            <a:r>
+              <a:rPr lang="en-US" sz="2400" dirty="0">
+                <a:solidFill>
+                  <a:srgbClr val="FF0000"/>
+                </a:solidFill>
+              </a:rPr>
+              <a:t>Light increases and soil N decreases leaf N allocation to photosynthesis</a:t>
+            </a:r>
+          </a:p>
+        </p:txBody>
+      </p:sp>
+      <p:pic>
+        <p:nvPicPr>
+          <p:cNvPr id="5" name="New picture">
+            <a:extLst>
+              <a:ext uri="{FF2B5EF4-FFF2-40B4-BE49-F238E27FC236}">
+                <a16:creationId xmlns:a16="http://schemas.microsoft.com/office/drawing/2014/main" id="{C62D95DF-4132-D77A-BA20-1897BD10C544}"/>
+              </a:ext>
+            </a:extLst>
+          </p:cNvPr>
+          <p:cNvPicPr/>
+          <p:nvPr/>
+        </p:nvPicPr>
+        <p:blipFill>
+          <a:blip r:embed="rId2"/>
+          <a:stretch>
+            <a:fillRect/>
+          </a:stretch>
+        </p:blipFill>
+        <p:spPr>
+          <a:xfrm>
+            <a:off x="6934201" y="1473108"/>
+            <a:ext cx="4582677" cy="4601871"/>
+          </a:xfrm>
+          <a:prstGeom prst="rect">
+            <a:avLst/>
+          </a:prstGeom>
+        </p:spPr>
+      </p:pic>
+      <p:sp>
+        <p:nvSpPr>
+          <p:cNvPr id="6" name="TextBox 5">
+            <a:extLst>
+              <a:ext uri="{FF2B5EF4-FFF2-40B4-BE49-F238E27FC236}">
+                <a16:creationId xmlns:a16="http://schemas.microsoft.com/office/drawing/2014/main" id="{9B53528B-9399-36A8-4BD9-4D15FA9FAB87}"/>
+              </a:ext>
+            </a:extLst>
+          </p:cNvPr>
+          <p:cNvSpPr txBox="1"/>
+          <p:nvPr/>
+        </p:nvSpPr>
+        <p:spPr>
+          <a:xfrm>
+            <a:off x="10104505" y="6488668"/>
+            <a:ext cx="2087495" cy="369332"/>
+          </a:xfrm>
+          <a:prstGeom prst="rect">
+            <a:avLst/>
+          </a:prstGeom>
+          <a:noFill/>
+        </p:spPr>
+        <p:txBody>
+          <a:bodyPr wrap="none" rtlCol="0">
+            <a:spAutoFit/>
+          </a:bodyPr>
+          <a:lstStyle/>
+          <a:p>
+            <a:r>
+              <a:rPr lang="en-US" dirty="0"/>
+              <a:t>Waring et al. (2023)</a:t>
             </a:r>
           </a:p>
         </p:txBody>
@@ -6469,7 +7333,7 @@
     </p:spTree>
     <p:extLst>
       <p:ext uri="{BB962C8B-B14F-4D97-AF65-F5344CB8AC3E}">
-        <p14:creationId xmlns:p14="http://schemas.microsoft.com/office/powerpoint/2010/main" val="3935558290"/>
+        <p14:creationId xmlns:p14="http://schemas.microsoft.com/office/powerpoint/2010/main" val="2639993323"/>
       </p:ext>
     </p:extLst>
   </p:cSld>

</xml_diff>